<commit_message>
docs(presentation): regenerate deck for UBI 10 (sections.py, build-pptx.py, pptx)
</commit_message>
<xml_diff>
--- a/presentation/cpp-container-tutorial.pptx
+++ b/presentation/cpp-container-tutorial.pptx
@@ -1172,7 +1172,7 @@
           <a:p>
             <a:r>
               <a:rPr sz="1200"/>
-              <a:t>Three variants we'll measure in Demo 1: single-stage naive (the anti-pattern, builder and runtime in one image, 689 MB); ubi-multistage (builder is ubi9, runtime is ubi9-minimal, 114 MB); ubi-micro (builder is ubi9, runtime is ubi9-micro with static libstdc++, 26 MB). Twenty-six-fold size reduction; same C++ source code; same runtime performance for our HTTP echo service. The only thing you trade is debug surface — ubi-micro has no shell, no package manager, no debugger.</a:t>
+              <a:t>Three variants we'll measure in Demo 1: single-stage naive (the anti-pattern, builder and runtime in one image, 689 MB); ubi-multistage (builder is ubi10/ubi, runtime is ubi10/ubi-minimal, 114 MB); ubi-micro (builder is ubi10/ubi, runtime is ubi10/ubi-micro with static libstdc++, 26 MB). Twenty-six-fold size reduction; same C++ source code; same runtime performance for our HTTP echo service. The only thing you trade is debug surface — ubi-micro has no shell, no package manager, no debugger.</a:t>
             </a:r>
           </a:p>
         </p:txBody>
@@ -1486,7 +1486,7 @@
           <a:p>
             <a:r>
               <a:rPr sz="1200"/>
-              <a:t>Here's the shape. Sections 1, 2, and 3 are setup and mental model: what we're optimizing, where the levers live, and the RAII discipline that the whole tutorial assumes. Sections 4 and 5 are compile-time work — image strategy and LTO/PGO — with Demo 1 as the worked example. Section 6 is the data-structure question; Demo 2. Section 7 is allocator strategy; Demo 6. Sections 8 and 9 are I/O and networking; Demo 3. Section 10 is observability — Demo 4 is the Grafana LGTM stack. Section 11 is noisy-neighbor isolation; Demo 5. Sections 12 and 13 are the engineering hygiene track: analysis, debugging, reproducibility, ABI; Demo 7. Section 14 is pitfalls — the runbook. Section 15 is reading pointers. Section 16 is an appendix you only need if you're doing Conan from-source on UBI 9.</a:t>
+              <a:t>Here's the shape. Sections 1, 2, and 3 are setup and mental model: what we're optimizing, where the levers live, and the RAII discipline that the whole tutorial assumes. Sections 4 and 5 are compile-time work — image strategy and LTO/PGO — with Demo 1 as the worked example. Section 6 is the data-structure question; Demo 2. Section 7 is allocator strategy; Demo 6. Sections 8 and 9 are I/O and networking; Demo 3. Section 10 is observability — Demo 4 is the Grafana LGTM stack. Section 11 is noisy-neighbor isolation; Demo 5. Sections 12 and 13 are the engineering hygiene track: analysis, debugging, reproducibility, ABI; Demo 7. Section 14 is pitfalls — the runbook. Section 15 is reading pointers. Section 16 is an appendix you only need if you're doing Conan from-source on UBI — the minimal-perl trap is a property of UBI's minimalism, not of any one release.</a:t>
             </a:r>
           </a:p>
           <a:p>
@@ -4183,7 +4183,7 @@
           <a:p>
             <a:r>
               <a:rPr sz="1200"/>
-              <a:t>Two columns. On the left, build-time: Conan manages dependencies and produces lockfiles; CMake plus Ninja drives the build; either GCC 14 from gcc-toolset or Clang 18 does the actual compilation. Standard hermetic build flow.</a:t>
+              <a:t>Two columns. On the left, build-time: Conan manages dependencies and produces lockfiles; CMake plus Ninja drives the build; either GCC 14 (base gcc/gcc-c++, 14.3.1) or Clang 18 does the actual compilation. Standard hermetic build flow.</a:t>
             </a:r>
           </a:p>
           <a:p>
@@ -4930,7 +4930,7 @@
           <a:p>
             <a:r>
               <a:rPr sz="1200"/>
-              <a:t>Third, the Containerfile pins the base image. UBI 9 with a specific digest hash, not just 'ubi9:latest'. If Red Hat ships a new ubi9 image, you don't pick it up until you explicitly update the digest.</a:t>
+              <a:t>Third, the Containerfile pins the base image. UBI 10 with a specific digest hash, not just 'ubi10/ubi:latest'. If Red Hat ships a new ubi10 image, you don't pick it up until you explicitly update the digest.</a:t>
             </a:r>
           </a:p>
           <a:p>
@@ -5873,7 +5873,7 @@
           <a:p>
             <a:r>
               <a:rPr sz="1200"/>
-              <a:t>Brief appendix. Read this one before you attempt your own Conan + UBI 9 + autotools-using-dep build. The tutorial's demo-04 took six rounds of build failures to converge, and every one of them was the same underlying issue: UBI 9's minimal perl is missing modules that autotools' configure scripts assume are present.</a:t>
+              <a:t>Brief appendix. Read this one before you attempt your own Conan + UBI + autotools-using-dep build. The tutorial's demo-04 took six rounds of build failures to converge. That war story played out on UBI 9; the tutorial now targets UBI 10 and the recipe below is updated to match — but the trap is a property of UBI's deliberate minimalism, not of any one release: UBI's minimal perl is missing modules that autotools' configure scripts assume are present.</a:t>
             </a:r>
           </a:p>
         </p:txBody>
@@ -5944,13 +5944,13 @@
           <a:p>
             <a:r>
               <a:rPr sz="1200"/>
-              <a:t>Fifteen perl modules. I'll spare you the bug history and just give you the list. If you're doing a Conan from-source build on UBI 9-minimal of anything that uses autotools — libcurl, c-ares, openssl, nghttp2, and most C libraries from the 90s — you need these fifteen modules.</a:t>
+              <a:t>Fifteen perl modules. I'll spare you the bug history and just give you the list. If you're doing a Conan from-source build on ubi10/ubi-minimal of anything that uses autotools — libcurl, c-ares, openssl, nghttp2, and most C libraries from the 90s — you need these fifteen modules.</a:t>
             </a:r>
           </a:p>
           <a:p>
             <a:r>
               <a:rPr sz="1200"/>
-              <a:t>Three simplifying alternatives. First and easiest: use the full ubi9 image for the builder stage. The runtime image can still be ubi9-minimal or ubi9-micro. Multi-stage means the builder bulk doesn't ship to production. The perl modules are in the builder only.</a:t>
+              <a:t>Three simplifying alternatives. First and easiest: use the full ubi10/ubi image for the builder stage. The runtime image can still be ubi10/ubi-minimal or ubi10/ubi-micro. Multi-stage means the builder bulk doesn't ship to production. The perl modules are in the builder only.</a:t>
             </a:r>
           </a:p>
           <a:p>
@@ -6104,19 +6104,19 @@
           <a:p>
             <a:r>
               <a:rPr sz="1200"/>
-              <a:t>The Containerfile fragment that actually works for libcurl-from-source on UBI 9. Builder stage installs the fifteen perl modules, plus the toolchain and Conan 2. Then `conan install --build=missing` works because the dependency's configure script can find all the perl modules it needs.</a:t>
+              <a:t>The Containerfile fragment that actually works for libcurl-from-source on UBI 10. Builder stage installs the fifteen perl modules, plus the toolchain and Conan 2. On UBI 10 the compiler is just base gcc/gcc-c++ 14.3.1 — no gcc-toolset software collection to enable. Then `conan install --build=missing` works because the dependency's configure script can find all the perl modules it needs.</a:t>
             </a:r>
           </a:p>
           <a:p>
             <a:r>
               <a:rPr sz="1200"/>
-              <a:t>Runtime stage is ubi9-micro, no perl at all, no compiler. Just the binary we copy from the builder. Final image is tens of megabytes, not hundreds. Builder image is large but only exists in your build cache, not in production registries.</a:t>
+              <a:t>Runtime stage is ubi10/ubi-micro, no perl at all, no compiler. Just the binary we copy from the builder. Final image is tens of megabytes, not hundreds. Builder image is large but only exists in your build cache, not in production registries.</a:t>
             </a:r>
           </a:p>
           <a:p>
             <a:r>
               <a:rPr sz="1200"/>
-              <a:t>This appendix exists because every team that goes from Ubuntu to UBI 9 hits this. The Ubuntu base images include a fuller perl by default; UBI 9 is more aggressive about minimization. The first time your Conan build fails on a missing perl-Errno module is when you realize what's going on. Save yourself the rounds.</a:t>
+              <a:t>This appendix exists because every team that goes from Ubuntu to UBI hits this. The Ubuntu base images include a fuller perl by default; UBI is more aggressive about minimization. The first time your Conan build fails on a missing perl-Errno module is when you realize what's going on. Save yourself the rounds.</a:t>
             </a:r>
           </a:p>
         </p:txBody>
@@ -13038,7 +13038,7 @@
                 <a:latin typeface="Calibri"/>
               </a:rPr>
               <a:t>ubi-multistage
-(ubi9 + ubi9-minimal)</a:t>
+(ubi10/ubi + ubi10/ubi-minimal)</a:t>
             </a:r>
           </a:p>
         </p:txBody>
@@ -15818,7 +15818,7 @@
                 </a:solidFill>
                 <a:latin typeface="Calibri"/>
               </a:rPr>
-              <a:t>Appendix — Conan + UBI 9 perl</a:t>
+              <a:t>Appendix — Conan + UBI's minimal perl</a:t>
             </a:r>
           </a:p>
         </p:txBody>
@@ -29381,7 +29381,7 @@
                 </a:solidFill>
                 <a:latin typeface="Calibri"/>
               </a:rPr>
-              <a:t>•  gcc-toolset-14 or Clang 18 — C++23, sanitizers, LTO/PGO (§5)</a:t>
+              <a:t>•  gcc/gcc-c++ 14.3.1 or Clang 18 — C++23, sanitizers, LTO/PGO (§5)</a:t>
             </a:r>
           </a:p>
           <a:p>
@@ -29445,7 +29445,7 @@
                 </a:solidFill>
                 <a:latin typeface="Calibri"/>
               </a:rPr>
-              <a:t>•  Base images: UBI 9 / ubi-micro / scratch — multi-stage in §4</a:t>
+              <a:t>•  Base images: UBI 10 / ubi-micro / scratch — multi-stage in §4</a:t>
             </a:r>
           </a:p>
           <a:p>
@@ -37415,7 +37415,7 @@
                 </a:solidFill>
                 <a:latin typeface="Calibri"/>
               </a:rPr>
-              <a:t>Appendix A — Conan, autotools, UBI 9's minimal perl</a:t>
+              <a:t>Appendix A — Conan, autotools, UBI's minimal perl</a:t>
             </a:r>
           </a:p>
         </p:txBody>
@@ -37450,7 +37450,7 @@
                 </a:solidFill>
                 <a:latin typeface="Calibri"/>
               </a:rPr>
-              <a:t>The survival guide for from-source dependency builds on UBI 9</a:t>
+              <a:t>The survival guide for from-source dependency builds on UBI</a:t>
             </a:r>
           </a:p>
         </p:txBody>
@@ -37589,7 +37589,7 @@
                 </a:solidFill>
                 <a:latin typeface="Calibri"/>
               </a:rPr>
-              <a:t>Appendix A — Conan, autotools, UBI 9's minimal perl</a:t>
+              <a:t>Appendix A — Conan, autotools, UBI's minimal perl</a:t>
             </a:r>
           </a:p>
         </p:txBody>
@@ -37704,7 +37704,7 @@
                 </a:solidFill>
                 <a:latin typeface="Calibri"/>
               </a:rPr>
-              <a:t>Optimizing Modern C++ with Containers   |   Appendix A — Conan, autotools, UBI 9's minimal perl</a:t>
+              <a:t>Optimizing Modern C++ with Containers   |   Appendix A — Conan, autotools, UBI's minimal perl</a:t>
             </a:r>
           </a:p>
         </p:txBody>
@@ -37813,7 +37813,7 @@
                 </a:solidFill>
                 <a:latin typeface="Calibri"/>
               </a:rPr>
-              <a:t>UBI 9's perl-interpreter is the minimal subset. Any autotools-based Conan build (libcurl, c-ares, openssl, nghttp2, etc.) will fail until these are installed:</a:t>
+              <a:t>UBI's perl-interpreter is the minimal subset. Any autotools-based Conan build (libcurl, c-ares, openssl, nghttp2, etc.) will fail until these are installed:</a:t>
             </a:r>
           </a:p>
           <a:p>
@@ -38005,7 +38005,7 @@
                 </a:solidFill>
                 <a:latin typeface="Calibri"/>
               </a:rPr>
-              <a:t>•  Use ubi9 (not ubi9-minimal) for the builder stage — includes full perl</a:t>
+              <a:t>•  Use ubi10/ubi (not ubi10/ubi-minimal) for the builder stage — includes full perl</a:t>
             </a:r>
           </a:p>
           <a:p>
@@ -38307,7 +38307,7 @@
                 </a:solidFill>
                 <a:latin typeface="Calibri"/>
               </a:rPr>
-              <a:t>Appendix A — Conan, autotools, UBI 9's minimal perl</a:t>
+              <a:t>Appendix A — Conan, autotools, UBI's minimal perl</a:t>
             </a:r>
           </a:p>
         </p:txBody>
@@ -38422,7 +38422,7 @@
                 </a:solidFill>
                 <a:latin typeface="Calibri"/>
               </a:rPr>
-              <a:t>Optimizing Modern C++ with Containers   |   Appendix A — Conan, autotools, UBI 9's minimal perl</a:t>
+              <a:t>Optimizing Modern C++ with Containers   |   Appendix A — Conan, autotools, UBI's minimal perl</a:t>
             </a:r>
           </a:p>
         </p:txBody>
@@ -38492,7 +38492,7 @@
                 </a:solidFill>
                 <a:latin typeface="Calibri"/>
               </a:rPr>
-              <a:t>Worked example — libcurl from source on UBI 9</a:t>
+              <a:t>Worked example — libcurl from source on UBI 10</a:t>
             </a:r>
           </a:p>
         </p:txBody>
@@ -38608,7 +38608,7 @@
                 </a:solidFill>
                 <a:latin typeface="Consolas"/>
               </a:rPr>
-              <a:t># Builder stage — full UBI 9 with the 15 perl modules</a:t>
+              <a:t># Builder stage — full UBI 10 with the 15 perl modules.</a:t>
             </a:r>
           </a:p>
           <a:p>
@@ -38619,7 +38619,7 @@
                 </a:solidFill>
                 <a:latin typeface="Consolas"/>
               </a:rPr>
-              <a:t>FROM registry.redhat.io/ubi9:9.4 AS builder</a:t>
+              <a:t># gcc/gcc-c++ (14.3.1) come straight from the base appstream —</a:t>
             </a:r>
           </a:p>
           <a:p>
@@ -38630,6 +38630,28 @@
                 </a:solidFill>
                 <a:latin typeface="Consolas"/>
               </a:rPr>
+              <a:t># no software collection, no `scl enable`; CRB is on by default.</a:t>
+            </a:r>
+          </a:p>
+          <a:p>
+            <a:r>
+              <a:rPr sz="1100">
+                <a:solidFill>
+                  <a:srgbClr val="ECF0F1"/>
+                </a:solidFill>
+                <a:latin typeface="Consolas"/>
+              </a:rPr>
+              <a:t>FROM registry.access.redhat.com/ubi10/ubi:10.2 AS builder</a:t>
+            </a:r>
+          </a:p>
+          <a:p>
+            <a:r>
+              <a:rPr sz="1100">
+                <a:solidFill>
+                  <a:srgbClr val="ECF0F1"/>
+                </a:solidFill>
+                <a:latin typeface="Consolas"/>
+              </a:rPr>
               <a:t> </a:t>
             </a:r>
           </a:p>
@@ -38696,7 +38718,7 @@
                 </a:solidFill>
                 <a:latin typeface="Consolas"/>
               </a:rPr>
-              <a:t>    gcc-toolset-14 cmake ninja-build python3-pip &amp;&amp; \</a:t>
+              <a:t>    gcc gcc-c++ cmake ninja-build python3-pip &amp;&amp; \</a:t>
             </a:r>
           </a:p>
           <a:p>
@@ -38828,7 +38850,7 @@
                 </a:solidFill>
                 <a:latin typeface="Consolas"/>
               </a:rPr>
-              <a:t>FROM registry.redhat.io/ubi9-micro:9.4</a:t>
+              <a:t>FROM registry.access.redhat.com/ubi10/ubi-micro:10.2</a:t>
             </a:r>
           </a:p>
           <a:p>

</xml_diff>

<commit_message>
feat(presentation): add "Take it with you" scan-to-explore QR slide (#4)
Left QR -> the cpp-container-optimization-tutorial site, right QR -> the
Workshops & Tutorials hub. Appended to the committed pptx.
</commit_message>
<xml_diff>
--- a/presentation/cpp-container-tutorial.pptx
+++ b/presentation/cpp-container-tutorial.pptx
@@ -76,6 +76,7 @@
     <p:sldId id="324" r:id="rId76"/>
     <p:sldId id="325" r:id="rId77"/>
     <p:sldId id="326" r:id="rId78"/>
+    <p:sldId id="327" r:id="rId79"/>
   </p:sldIdLst>
   <p:sldSz cx="12191695" cy="6858000" type="screen4x3"/>
   <p:notesSz cx="6858000" cy="9144000"/>
@@ -39319,6 +39320,428 @@
           </a:p>
         </p:txBody>
       </p:sp>
+    </p:spTree>
+  </p:cSld>
+  <p:clrMapOvr>
+    <a:masterClrMapping/>
+  </p:clrMapOvr>
+</p:sld>
+</file>
+
+<file path=ppt/slides/slide72.xml><?xml version="1.0" encoding="utf-8"?>
+<p:sld xmlns:a="http://schemas.openxmlformats.org/drawingml/2006/main" xmlns:p="http://schemas.openxmlformats.org/presentationml/2006/main" xmlns:r="http://schemas.openxmlformats.org/officeDocument/2006/relationships">
+  <p:bg>
+    <p:bgPr>
+      <a:solidFill>
+        <a:srgbClr val="FFFFFF"/>
+      </a:solidFill>
+      <a:effectLst/>
+    </p:bgPr>
+  </p:bg>
+  <p:cSld>
+    <p:spTree>
+      <p:nvGrpSpPr>
+        <p:cNvPr id="1" name=""/>
+        <p:cNvGrpSpPr/>
+        <p:nvPr/>
+      </p:nvGrpSpPr>
+      <p:grpSpPr/>
+      <p:sp>
+        <p:nvSpPr>
+          <p:cNvPr id="2" name="TextBox 1"/>
+          <p:cNvSpPr txBox="1"/>
+          <p:nvPr/>
+        </p:nvSpPr>
+        <p:spPr>
+          <a:xfrm>
+            <a:off x="566927" y="384047"/>
+            <a:ext cx="11055095" cy="292607"/>
+          </a:xfrm>
+          <a:prstGeom prst="rect">
+            <a:avLst/>
+          </a:prstGeom>
+          <a:noFill/>
+        </p:spPr>
+        <p:txBody>
+          <a:bodyPr wrap="square" lIns="0" rIns="0" tIns="0" bIns="0" anchor="ctr">
+            <a:spAutoFit/>
+          </a:bodyPr>
+          <a:lstStyle/>
+          <a:p>
+            <a:pPr algn="l"/>
+            <a:r>
+              <a:rPr sz="1199" b="1" i="0" spc="399">
+                <a:solidFill>
+                  <a:srgbClr val="EE0000"/>
+                </a:solidFill>
+                <a:latin typeface="Overpass"/>
+                <a:cs typeface="Overpass"/>
+              </a:rPr>
+              <a:t>SCAN TO EXPLORE</a:t>
+            </a:r>
+          </a:p>
+        </p:txBody>
+      </p:sp>
+      <p:sp>
+        <p:nvSpPr>
+          <p:cNvPr id="3" name="TextBox 2"/>
+          <p:cNvSpPr txBox="1"/>
+          <p:nvPr/>
+        </p:nvSpPr>
+        <p:spPr>
+          <a:xfrm>
+            <a:off x="566927" y="676655"/>
+            <a:ext cx="11055095" cy="1005839"/>
+          </a:xfrm>
+          <a:prstGeom prst="rect">
+            <a:avLst/>
+          </a:prstGeom>
+          <a:noFill/>
+        </p:spPr>
+        <p:txBody>
+          <a:bodyPr wrap="square" lIns="0" rIns="0" tIns="0" bIns="0" anchor="t">
+            <a:spAutoFit/>
+          </a:bodyPr>
+          <a:lstStyle/>
+          <a:p>
+            <a:pPr algn="l"/>
+            <a:r>
+              <a:rPr sz="2999" b="1" i="0">
+                <a:solidFill>
+                  <a:srgbClr val="151515"/>
+                </a:solidFill>
+                <a:latin typeface="Overpass"/>
+                <a:cs typeface="Overpass"/>
+              </a:rPr>
+              <a:t>Take it with you</a:t>
+            </a:r>
+          </a:p>
+        </p:txBody>
+      </p:sp>
+      <p:pic>
+        <p:nvPicPr>
+          <p:cNvPr id="4" name="Picture 3" descr="qr-cppct-site.png"/>
+          <p:cNvPicPr>
+            <a:picLocks noChangeAspect="1"/>
+          </p:cNvPicPr>
+          <p:nvPr/>
+        </p:nvPicPr>
+        <p:blipFill>
+          <a:blip r:embed="rId2"/>
+          <a:stretch>
+            <a:fillRect/>
+          </a:stretch>
+        </p:blipFill>
+        <p:spPr>
+          <a:xfrm>
+            <a:off x="2103119" y="1627631"/>
+            <a:ext cx="2834639" cy="2834639"/>
+          </a:xfrm>
+          <a:prstGeom prst="rect">
+            <a:avLst/>
+          </a:prstGeom>
+        </p:spPr>
+      </p:pic>
+      <p:sp>
+        <p:nvSpPr>
+          <p:cNvPr id="5" name="TextBox 4"/>
+          <p:cNvSpPr txBox="1"/>
+          <p:nvPr/>
+        </p:nvSpPr>
+        <p:spPr>
+          <a:xfrm>
+            <a:off x="1417319" y="4553711"/>
+            <a:ext cx="4206239" cy="365759"/>
+          </a:xfrm>
+          <a:prstGeom prst="rect">
+            <a:avLst/>
+          </a:prstGeom>
+          <a:noFill/>
+        </p:spPr>
+        <p:txBody>
+          <a:bodyPr wrap="square" lIns="0" rIns="0" tIns="0" bIns="0" anchor="ctr">
+            <a:spAutoFit/>
+          </a:bodyPr>
+          <a:lstStyle/>
+          <a:p>
+            <a:pPr algn="ctr"/>
+            <a:r>
+              <a:rPr sz="1799" b="1" i="0">
+                <a:solidFill>
+                  <a:srgbClr val="151515"/>
+                </a:solidFill>
+                <a:latin typeface="Overpass"/>
+                <a:cs typeface="Overpass"/>
+              </a:rPr>
+              <a:t>The site</a:t>
+            </a:r>
+          </a:p>
+        </p:txBody>
+      </p:sp>
+      <p:sp>
+        <p:nvSpPr>
+          <p:cNvPr id="6" name="TextBox 5"/>
+          <p:cNvSpPr txBox="1"/>
+          <p:nvPr/>
+        </p:nvSpPr>
+        <p:spPr>
+          <a:xfrm>
+            <a:off x="1325879" y="4937759"/>
+            <a:ext cx="4389119" cy="658367"/>
+          </a:xfrm>
+          <a:prstGeom prst="rect">
+            <a:avLst/>
+          </a:prstGeom>
+          <a:noFill/>
+        </p:spPr>
+        <p:txBody>
+          <a:bodyPr wrap="square" lIns="0" rIns="0" tIns="0" bIns="0" anchor="t">
+            <a:spAutoFit/>
+          </a:bodyPr>
+          <a:lstStyle/>
+          <a:p>
+            <a:pPr algn="ctr"/>
+            <a:r>
+              <a:rPr sz="1299" b="0" i="1">
+                <a:solidFill>
+                  <a:srgbClr val="5A5A5A"/>
+                </a:solidFill>
+                <a:latin typeface="Red Hat Text"/>
+                <a:cs typeface="Red Hat Text"/>
+              </a:rPr>
+              <a:t>Chapters, the runnable examples, and the benchmarks</a:t>
+            </a:r>
+          </a:p>
+        </p:txBody>
+      </p:sp>
+      <p:sp>
+        <p:nvSpPr>
+          <p:cNvPr id="7" name="TextBox 6"/>
+          <p:cNvSpPr txBox="1"/>
+          <p:nvPr/>
+        </p:nvSpPr>
+        <p:spPr>
+          <a:xfrm>
+            <a:off x="1325879" y="5596127"/>
+            <a:ext cx="4389119" cy="292607"/>
+          </a:xfrm>
+          <a:prstGeom prst="rect">
+            <a:avLst/>
+          </a:prstGeom>
+          <a:noFill/>
+        </p:spPr>
+        <p:txBody>
+          <a:bodyPr wrap="square" lIns="0" rIns="0" tIns="0" bIns="0" anchor="ctr">
+            <a:spAutoFit/>
+          </a:bodyPr>
+          <a:lstStyle/>
+          <a:p>
+            <a:pPr algn="ctr"/>
+            <a:r>
+              <a:rPr sz="899" b="0" i="0">
+                <a:solidFill>
+                  <a:srgbClr val="EE0000"/>
+                </a:solidFill>
+                <a:latin typeface="Red Hat Mono"/>
+                <a:cs typeface="Red Hat Mono"/>
+              </a:rPr>
+              <a:t>patterncatalyst.github.io/cpp-container-optimization-tutorial</a:t>
+            </a:r>
+          </a:p>
+        </p:txBody>
+      </p:sp>
+      <p:pic>
+        <p:nvPicPr>
+          <p:cNvPr id="8" name="Picture 7" descr="qr-hub.png"/>
+          <p:cNvPicPr>
+            <a:picLocks noChangeAspect="1"/>
+          </p:cNvPicPr>
+          <p:nvPr/>
+        </p:nvPicPr>
+        <p:blipFill>
+          <a:blip r:embed="rId3"/>
+          <a:stretch>
+            <a:fillRect/>
+          </a:stretch>
+        </p:blipFill>
+        <p:spPr>
+          <a:xfrm>
+            <a:off x="7251191" y="1627631"/>
+            <a:ext cx="2834639" cy="2834639"/>
+          </a:xfrm>
+          <a:prstGeom prst="rect">
+            <a:avLst/>
+          </a:prstGeom>
+        </p:spPr>
+      </p:pic>
+      <p:sp>
+        <p:nvSpPr>
+          <p:cNvPr id="9" name="TextBox 8"/>
+          <p:cNvSpPr txBox="1"/>
+          <p:nvPr/>
+        </p:nvSpPr>
+        <p:spPr>
+          <a:xfrm>
+            <a:off x="6565391" y="4553711"/>
+            <a:ext cx="4206239" cy="365759"/>
+          </a:xfrm>
+          <a:prstGeom prst="rect">
+            <a:avLst/>
+          </a:prstGeom>
+          <a:noFill/>
+        </p:spPr>
+        <p:txBody>
+          <a:bodyPr wrap="square" lIns="0" rIns="0" tIns="0" bIns="0" anchor="ctr">
+            <a:spAutoFit/>
+          </a:bodyPr>
+          <a:lstStyle/>
+          <a:p>
+            <a:pPr algn="ctr"/>
+            <a:r>
+              <a:rPr sz="1799" b="1" i="0">
+                <a:solidFill>
+                  <a:srgbClr val="151515"/>
+                </a:solidFill>
+                <a:latin typeface="Overpass"/>
+                <a:cs typeface="Overpass"/>
+              </a:rPr>
+              <a:t>Workshops &amp; Tutorials</a:t>
+            </a:r>
+          </a:p>
+        </p:txBody>
+      </p:sp>
+      <p:sp>
+        <p:nvSpPr>
+          <p:cNvPr id="10" name="TextBox 9"/>
+          <p:cNvSpPr txBox="1"/>
+          <p:nvPr/>
+        </p:nvSpPr>
+        <p:spPr>
+          <a:xfrm>
+            <a:off x="6473951" y="4937759"/>
+            <a:ext cx="4389119" cy="658367"/>
+          </a:xfrm>
+          <a:prstGeom prst="rect">
+            <a:avLst/>
+          </a:prstGeom>
+          <a:noFill/>
+        </p:spPr>
+        <p:txBody>
+          <a:bodyPr wrap="square" lIns="0" rIns="0" tIns="0" bIns="0" anchor="t">
+            <a:spAutoFit/>
+          </a:bodyPr>
+          <a:lstStyle/>
+          <a:p>
+            <a:pPr algn="ctr"/>
+            <a:r>
+              <a:rPr sz="1299" b="0" i="1">
+                <a:solidFill>
+                  <a:srgbClr val="5A5A5A"/>
+                </a:solidFill>
+                <a:latin typeface="Red Hat Text"/>
+                <a:cs typeface="Red Hat Text"/>
+              </a:rPr>
+              <a:t>The whole series: every workshop, tutorial, and deck in one place</a:t>
+            </a:r>
+          </a:p>
+        </p:txBody>
+      </p:sp>
+      <p:sp>
+        <p:nvSpPr>
+          <p:cNvPr id="11" name="TextBox 10"/>
+          <p:cNvSpPr txBox="1"/>
+          <p:nvPr/>
+        </p:nvSpPr>
+        <p:spPr>
+          <a:xfrm>
+            <a:off x="6473951" y="5596127"/>
+            <a:ext cx="4389119" cy="292607"/>
+          </a:xfrm>
+          <a:prstGeom prst="rect">
+            <a:avLst/>
+          </a:prstGeom>
+          <a:noFill/>
+        </p:spPr>
+        <p:txBody>
+          <a:bodyPr wrap="square" lIns="0" rIns="0" tIns="0" bIns="0" anchor="ctr">
+            <a:spAutoFit/>
+          </a:bodyPr>
+          <a:lstStyle/>
+          <a:p>
+            <a:pPr algn="ctr"/>
+            <a:r>
+              <a:rPr sz="899" b="0" i="0">
+                <a:solidFill>
+                  <a:srgbClr val="EE0000"/>
+                </a:solidFill>
+                <a:latin typeface="Red Hat Mono"/>
+                <a:cs typeface="Red Hat Mono"/>
+              </a:rPr>
+              <a:t>patterncatalyst.github.io/patterncatalyst-workshops-tutorials-list</a:t>
+            </a:r>
+          </a:p>
+        </p:txBody>
+      </p:sp>
+      <p:sp>
+        <p:nvSpPr>
+          <p:cNvPr id="12" name="TextBox 11"/>
+          <p:cNvSpPr txBox="1"/>
+          <p:nvPr/>
+        </p:nvSpPr>
+        <p:spPr>
+          <a:xfrm>
+            <a:off x="566927" y="6364223"/>
+            <a:ext cx="914399" cy="274319"/>
+          </a:xfrm>
+          <a:prstGeom prst="rect">
+            <a:avLst/>
+          </a:prstGeom>
+          <a:noFill/>
+        </p:spPr>
+        <p:txBody>
+          <a:bodyPr wrap="square" lIns="0" rIns="0" tIns="0" bIns="0" anchor="ctr">
+            <a:spAutoFit/>
+          </a:bodyPr>
+          <a:lstStyle/>
+          <a:p>
+            <a:pPr algn="l"/>
+            <a:r>
+              <a:rPr sz="999" b="0" i="0">
+                <a:solidFill>
+                  <a:srgbClr val="8A8A8A"/>
+                </a:solidFill>
+                <a:latin typeface="Red Hat Text"/>
+                <a:cs typeface="Red Hat Text"/>
+              </a:rPr>
+              <a:t>72</a:t>
+            </a:r>
+          </a:p>
+        </p:txBody>
+      </p:sp>
+      <p:pic>
+        <p:nvPicPr>
+          <p:cNvPr id="13" name="Picture 12" descr="logo-candidate-2.png"/>
+          <p:cNvPicPr>
+            <a:picLocks noChangeAspect="1"/>
+          </p:cNvPicPr>
+          <p:nvPr/>
+        </p:nvPicPr>
+        <p:blipFill>
+          <a:blip r:embed="rId4"/>
+          <a:stretch>
+            <a:fillRect/>
+          </a:stretch>
+        </p:blipFill>
+        <p:spPr>
+          <a:xfrm>
+            <a:off x="10561319" y="6355079"/>
+            <a:ext cx="1033271" cy="246887"/>
+          </a:xfrm>
+          <a:prstGeom prst="rect">
+            <a:avLst/>
+          </a:prstGeom>
+        </p:spPr>
+      </p:pic>
     </p:spTree>
   </p:cSld>
   <p:clrMapOvr>

</xml_diff>